<commit_message>
Sync deck to merged dashboard + add per-slide pitch notes
- pitch/build_deck.py: slide 3 ("Productos Tecnicos" -> "Technical
  products"), slide 7 demo steps now reflect the 3-tab structure
  (Client view / Monitoring / Learning loop) instead of old single
  Alerts tab.
- pitch/Smart_Demand_Signals.pptx regenerated.
- pitch/pitch_notes.md: word-for-word talk track per slide with
  timing cues, demo-flow choreography, and Q&A backup answers.

Co-Authored-By: Claude Opus 4.7 (1M context) <noreply@anthropic.com>
</commit_message>
<xml_diff>
--- a/pitch/Smart_Demand_Signals.pptx
+++ b/pitch/Smart_Demand_Signals.pptx
@@ -5201,7 +5201,7 @@
                 </a:solidFill>
                 <a:latin typeface="Calibri"/>
               </a:rPr>
-              <a:t>PRODUCTOS TÉCNICOS</a:t>
+              <a:t>TECHNICAL PRODUCTS</a:t>
             </a:r>
           </a:p>
         </p:txBody>
@@ -5236,7 +5236,7 @@
                 </a:solidFill>
                 <a:latin typeface="Calibri"/>
               </a:rPr>
-              <a:t>Biomateriales</a:t>
+              <a:t>Biomaterials</a:t>
             </a:r>
           </a:p>
         </p:txBody>
@@ -8057,7 +8057,7 @@
                 </a:solidFill>
                 <a:latin typeface="Calibri"/>
               </a:rPr>
-              <a:t>Daily cadence</a:t>
+              <a:t>Client view — one clinic, one action</a:t>
             </a:r>
           </a:p>
         </p:txBody>
@@ -8092,7 +8092,7 @@
                 </a:solidFill>
                 <a:latin typeface="Calibri"/>
               </a:rPr>
-              <a:t>Drag the date picker back to 2024-06-30. The alert table changes. Same code, any historical date — the system is idempotent.</a:t>
+              <a:t>Pick a high-score client. See the 4-category banner: Lost / Loss risk / Opportunity / Healthy. Each gives one concrete next step — not a label.</a:t>
             </a:r>
           </a:p>
         </p:txBody>
@@ -8205,7 +8205,7 @@
                 </a:solidFill>
                 <a:latin typeface="Calibri"/>
               </a:rPr>
-              <a:t>Drill into one alert</a:t>
+              <a:t>Monitoring — daily cadence + drill-down</a:t>
             </a:r>
           </a:p>
         </p:txBody>
@@ -8240,7 +8240,7 @@
                 </a:solidFill>
                 <a:latin typeface="Calibri"/>
               </a:rPr>
-              <a:t>Pick the top alert. Read the motivo. Click Trace features. See the raw numbers that fired it. No black box.</a:t>
+              <a:t>Switch the date back to 2024-06-30. Same code, different alerts. Filter to High priority. Export top-N as HubSpot Tasks JSON.</a:t>
             </a:r>
           </a:p>
         </p:txBody>
@@ -8353,7 +8353,7 @@
                 </a:solidFill>
                 <a:latin typeface="Calibri"/>
               </a:rPr>
-              <a:t>Learning loop</a:t>
+              <a:t>Learning loop — system improving over time</a:t>
             </a:r>
           </a:p>
         </p:txBody>
@@ -8388,7 +8388,7 @@
                 </a:solidFill>
                 <a:latin typeface="Calibri"/>
               </a:rPr>
-              <a:t>Switch to the Learning loop tab. 120 mocked outcomes show the system self-tuning: capture_window converts at 33%, silent at 11%.</a:t>
+              <a:t>120 mocked outcomes seed the metrics. Conversion by tipo: capture 33%, silent 11%. The system suggests threshold adjustments automatically.</a:t>
             </a:r>
           </a:p>
         </p:txBody>

</xml_diff>